<commit_message>
Add business applications slide and document prompt formats
</commit_message>
<xml_diff>
--- a/Twin_2K_500_Experiments.pptx
+++ b/Twin_2K_500_Experiments.pptx
@@ -2,29 +2,30 @@
 <file path=ppt/presentation.xml><?xml version="1.0" encoding="utf-8"?>
 <p:presentation xmlns:p="http://schemas.openxmlformats.org/presentationml/2006/main">
   <p:sldMasterIdLst>
-    <p:sldMasterId xmlns:r="http://schemas.openxmlformats.org/officeDocument/2006/relationships" id="2147483648" r:id="Rd547659f338e4535"/>
+    <p:sldMasterId xmlns:r="http://schemas.openxmlformats.org/officeDocument/2006/relationships" id="2147483648" r:id="Rf6242140c12240b9"/>
   </p:sldMasterIdLst>
   <p:notesMasterIdLst>
-    <p:notesMasterId xmlns:r="http://schemas.openxmlformats.org/officeDocument/2006/relationships" r:id="R1749407fa97c478b"/>
+    <p:notesMasterId xmlns:r="http://schemas.openxmlformats.org/officeDocument/2006/relationships" r:id="R1532d3055d2e4b20"/>
   </p:notesMasterIdLst>
   <p:sldIdLst>
-    <p:sldId xmlns:r="http://schemas.openxmlformats.org/officeDocument/2006/relationships" id="256" r:id="R09fb7051af394491"/>
-    <p:sldId xmlns:r="http://schemas.openxmlformats.org/officeDocument/2006/relationships" id="257" r:id="R27ffa9ece0fc462f"/>
-    <p:sldId xmlns:r="http://schemas.openxmlformats.org/officeDocument/2006/relationships" id="258" r:id="Ra9d6118135ae40c6"/>
-    <p:sldId xmlns:r="http://schemas.openxmlformats.org/officeDocument/2006/relationships" id="259" r:id="Rc5b3a9912e8f4208"/>
-    <p:sldId xmlns:r="http://schemas.openxmlformats.org/officeDocument/2006/relationships" id="260" r:id="R653c01b185ca4a8c"/>
-    <p:sldId xmlns:r="http://schemas.openxmlformats.org/officeDocument/2006/relationships" id="261" r:id="R7d2851b3bb624cb0"/>
-    <p:sldId xmlns:r="http://schemas.openxmlformats.org/officeDocument/2006/relationships" id="262" r:id="Rfc4e89eeb02f4478"/>
-    <p:sldId xmlns:r="http://schemas.openxmlformats.org/officeDocument/2006/relationships" id="263" r:id="Rc5f783b666e04cc2"/>
-    <p:sldId xmlns:r="http://schemas.openxmlformats.org/officeDocument/2006/relationships" id="264" r:id="R04ca0942df2941a4"/>
-    <p:sldId xmlns:r="http://schemas.openxmlformats.org/officeDocument/2006/relationships" id="265" r:id="Rec770c76bef54a04"/>
-    <p:sldId xmlns:r="http://schemas.openxmlformats.org/officeDocument/2006/relationships" id="266" r:id="R4e47ffa6ebfd44d5"/>
-    <p:sldId xmlns:r="http://schemas.openxmlformats.org/officeDocument/2006/relationships" id="267" r:id="Rfffe3d8e4259449a"/>
-    <p:sldId xmlns:r="http://schemas.openxmlformats.org/officeDocument/2006/relationships" id="268" r:id="R9099c4241f464ec4"/>
-    <p:sldId xmlns:r="http://schemas.openxmlformats.org/officeDocument/2006/relationships" id="269" r:id="R9c2f98a9577c498d"/>
-    <p:sldId xmlns:r="http://schemas.openxmlformats.org/officeDocument/2006/relationships" id="270" r:id="R5d019f315f504382"/>
-    <p:sldId xmlns:r="http://schemas.openxmlformats.org/officeDocument/2006/relationships" id="271" r:id="Ra336f5a2a6c4475d"/>
-    <p:sldId xmlns:r="http://schemas.openxmlformats.org/officeDocument/2006/relationships" id="272" r:id="R486880e3c45948a3"/>
+    <p:sldId xmlns:r="http://schemas.openxmlformats.org/officeDocument/2006/relationships" id="256" r:id="R2ea84dcce03a4ca1"/>
+    <p:sldId xmlns:r="http://schemas.openxmlformats.org/officeDocument/2006/relationships" id="257" r:id="Rf4f7c55254fa47ea"/>
+    <p:sldId xmlns:r="http://schemas.openxmlformats.org/officeDocument/2006/relationships" id="258" r:id="R4581a8a81efa4502"/>
+    <p:sldId xmlns:r="http://schemas.openxmlformats.org/officeDocument/2006/relationships" id="259" r:id="Rab661556b0494f9c"/>
+    <p:sldId xmlns:r="http://schemas.openxmlformats.org/officeDocument/2006/relationships" id="260" r:id="R13b9835a8f0845b2"/>
+    <p:sldId xmlns:r="http://schemas.openxmlformats.org/officeDocument/2006/relationships" id="261" r:id="R2b734af0b8bb4451"/>
+    <p:sldId xmlns:r="http://schemas.openxmlformats.org/officeDocument/2006/relationships" id="262" r:id="R4b33099dc4fe437c"/>
+    <p:sldId xmlns:r="http://schemas.openxmlformats.org/officeDocument/2006/relationships" id="263" r:id="R1c8ad2ccd7ec43b4"/>
+    <p:sldId xmlns:r="http://schemas.openxmlformats.org/officeDocument/2006/relationships" id="264" r:id="Ra3cf4b75a33c4bd7"/>
+    <p:sldId xmlns:r="http://schemas.openxmlformats.org/officeDocument/2006/relationships" id="265" r:id="Rad616cf36846485a"/>
+    <p:sldId xmlns:r="http://schemas.openxmlformats.org/officeDocument/2006/relationships" id="266" r:id="Rd5b6a1ad81084c75"/>
+    <p:sldId xmlns:r="http://schemas.openxmlformats.org/officeDocument/2006/relationships" id="267" r:id="R77bfff7af29e4c84"/>
+    <p:sldId xmlns:r="http://schemas.openxmlformats.org/officeDocument/2006/relationships" id="268" r:id="R76c6981c97684894"/>
+    <p:sldId xmlns:r="http://schemas.openxmlformats.org/officeDocument/2006/relationships" id="269" r:id="R1ee4eb2a0c4a4b8c"/>
+    <p:sldId xmlns:r="http://schemas.openxmlformats.org/officeDocument/2006/relationships" id="270" r:id="Rd488ae7977f14b9f"/>
+    <p:sldId xmlns:r="http://schemas.openxmlformats.org/officeDocument/2006/relationships" id="271" r:id="R303745e7d5be4fb0"/>
+    <p:sldId xmlns:r="http://schemas.openxmlformats.org/officeDocument/2006/relationships" id="272" r:id="R800e542d24744966"/>
+    <p:sldId xmlns:r="http://schemas.openxmlformats.org/officeDocument/2006/relationships" id="273" r:id="R5d2d7000a76144ee"/>
   </p:sldIdLst>
   <p:sldSz cx="12192000" cy="6858000"/>
   <p:notesSz cx="6858000" cy="9144000"/>
@@ -1112,6 +1113,76 @@
           <a:lstStyle xmlns:a="http://schemas.openxmlformats.org/drawingml/2006/main"/>
           <a:p xmlns:a="http://schemas.openxmlformats.org/drawingml/2006/main">
             <a:r>
+              <a:t>These are proposed applications, not demonstrated deployment capabilities. The current study does not establish reliable improvements in individual prediction over strong baselines. Retail research could use aggregate responses within validated products and price ranges to prioritize real customer studies; this does not authorize individualized pricing. Product/UX use would need separate validation for new wording, question formats and populations. Research use is exploratory and does not establish causal effects. Use only data with appropriate consent and access controls, avoid identifying profiles, and label outputs as synthetic estimates. Validate on fresh real respondents and evaluate uncertainty, subgroup errors and population mismatch before business decisions. Prohibited uses include high-stakes individual decisions, covert profiling or manipulation, impersonation, and substituting simulated answers for real evidence.</a:t>
+            </a:r>
+          </a:p>
+        </p:txBody>
+      </p:sp>
+      <p:sp>
+        <p:nvSpPr>
+          <p:cNvPr id="4" name="Slide Number Placeholder 3"/>
+          <p:cNvSpPr>
+            <a:spLocks xmlns:a="http://schemas.openxmlformats.org/drawingml/2006/main" noGrp="1"/>
+          </p:cNvSpPr>
+          <p:nvPr>
+            <p:ph type="sldNum" idx="5"/>
+          </p:nvPr>
+        </p:nvSpPr>
+        <p:spPr/>
+        <p:txBody>
+          <a:bodyPr xmlns:a="http://schemas.openxmlformats.org/drawingml/2006/main"/>
+          <a:lstStyle xmlns:a="http://schemas.openxmlformats.org/drawingml/2006/main"/>
+          <a:p xmlns:a="http://schemas.openxmlformats.org/drawingml/2006/main"/>
+        </p:txBody>
+      </p:sp>
+    </p:spTree>
+  </p:cSld>
+  <p:clrMapOvr>
+    <a:masterClrMapping xmlns:a="http://schemas.openxmlformats.org/drawingml/2006/main"/>
+  </p:clrMapOvr>
+</p:notes>
+</file>
+
+<file path=ppt/notesSlides/notesSlide18.xml><?xml version="1.0" encoding="utf-8"?>
+<p:notes xmlns:p="http://schemas.openxmlformats.org/presentationml/2006/main">
+  <p:cSld>
+    <p:spTree>
+      <p:nvGrpSpPr>
+        <p:cNvPr id="1" name=""/>
+        <p:cNvGrpSpPr/>
+        <p:nvPr/>
+      </p:nvGrpSpPr>
+      <p:grpSpPr>
+        <a:xfrm xmlns:a="http://schemas.openxmlformats.org/drawingml/2006/main"/>
+      </p:grpSpPr>
+      <p:sp>
+        <p:nvSpPr>
+          <p:cNvPr id="2" name="Slide Image Placeholder 1"/>
+          <p:cNvSpPr>
+            <a:spLocks xmlns:a="http://schemas.openxmlformats.org/drawingml/2006/main" noGrp="1"/>
+          </p:cNvSpPr>
+          <p:nvPr>
+            <p:ph type="sldImg" idx="0"/>
+          </p:nvPr>
+        </p:nvSpPr>
+        <p:spPr/>
+      </p:sp>
+      <p:sp>
+        <p:nvSpPr>
+          <p:cNvPr id="3" name="Notes Placeholder 2"/>
+          <p:cNvSpPr>
+            <a:spLocks xmlns:a="http://schemas.openxmlformats.org/drawingml/2006/main" noGrp="1"/>
+          </p:cNvSpPr>
+          <p:nvPr>
+            <p:ph type="body" idx="1"/>
+          </p:nvPr>
+        </p:nvSpPr>
+        <p:spPr/>
+        <p:txBody>
+          <a:bodyPr xmlns:a="http://schemas.openxmlformats.org/drawingml/2006/main"/>
+          <a:lstStyle xmlns:a="http://schemas.openxmlformats.org/drawingml/2006/main"/>
+          <a:p xmlns:a="http://schemas.openxmlformats.org/drawingml/2006/main">
+            <a:r>
               <a:t>The strongest conclusion is about evaluation discipline: question-only baselines are difficult to beat, and matching their score does not establish personalization. Full-B ablations show profile sensitivity, while retrieval changes show representation matters. These are repeatedly used development results. A final claim should come from one frozen evaluation on the reserved participants, with uncertainty computed at participant level and with the baseline measured on the same cases.</a:t>
             </a:r>
           </a:p>
@@ -3580,12 +3651,12 @@
   </p:cSld>
   <p:clrMap bg1="lt1" tx1="dk1" bg2="lt2" tx2="dk2" accent1="accent1" accent2="accent2" accent3="accent3" accent4="accent4" accent5="accent5" accent6="accent6" hlink="hlink" folHlink="folHlink"/>
   <p:sldLayoutIdLst>
-    <p:sldLayoutId xmlns:r="http://schemas.openxmlformats.org/officeDocument/2006/relationships" id="2147483649" r:id="R8d5b3fdb4da3494d"/>
-    <p:sldLayoutId xmlns:r="http://schemas.openxmlformats.org/officeDocument/2006/relationships" id="2147483650" r:id="Rc466de5579b9405c"/>
-    <p:sldLayoutId xmlns:r="http://schemas.openxmlformats.org/officeDocument/2006/relationships" id="2147483651" r:id="Ra3c7c6cb6ca6424d"/>
-    <p:sldLayoutId xmlns:r="http://schemas.openxmlformats.org/officeDocument/2006/relationships" id="2147483652" r:id="R3e331590a40a4f0a"/>
-    <p:sldLayoutId xmlns:r="http://schemas.openxmlformats.org/officeDocument/2006/relationships" id="2147483653" r:id="Rf65a5ed5b2af4ec2"/>
-    <p:sldLayoutId xmlns:r="http://schemas.openxmlformats.org/officeDocument/2006/relationships" id="2147483654" r:id="R8be77c222dc34479"/>
+    <p:sldLayoutId xmlns:r="http://schemas.openxmlformats.org/officeDocument/2006/relationships" id="2147483649" r:id="R7b2448f4df3546ea"/>
+    <p:sldLayoutId xmlns:r="http://schemas.openxmlformats.org/officeDocument/2006/relationships" id="2147483650" r:id="Rbe70d4eda563488e"/>
+    <p:sldLayoutId xmlns:r="http://schemas.openxmlformats.org/officeDocument/2006/relationships" id="2147483651" r:id="Rca18e24493f7412a"/>
+    <p:sldLayoutId xmlns:r="http://schemas.openxmlformats.org/officeDocument/2006/relationships" id="2147483652" r:id="Re7e5c9e106df44ad"/>
+    <p:sldLayoutId xmlns:r="http://schemas.openxmlformats.org/officeDocument/2006/relationships" id="2147483653" r:id="R4d69e3018d7742f1"/>
+    <p:sldLayoutId xmlns:r="http://schemas.openxmlformats.org/officeDocument/2006/relationships" id="2147483654" r:id="R48da20496749405e"/>
   </p:sldLayoutIdLst>
   <p:txStyles>
     <p:titleStyle>
@@ -4565,7 +4636,7 @@
           <p:cNvPr id="3" name="">
             <a:extLst xmlns:a="http://schemas.openxmlformats.org/drawingml/2006/main">
               <a:ext uri="{FF2B5EF4-FFF2-40B4-BE49-F238E27FC236}">
-                <a16:creationId xmlns:a16="http://schemas.microsoft.com/office/drawing/2014/main" id="{42142E13-D106-434D-A7C4-2139AF7F4FE6}"/>
+                <a16:creationId xmlns:a16="http://schemas.microsoft.com/office/drawing/2014/main" id="{82CE6439-DC02-4EFE-9C5A-8C5CDC2AE276}"/>
               </a:ext>
             </a:extLst>
           </p:cNvPr>
@@ -4575,7 +4646,7 @@
           <p:nvPr/>
         </p:nvPicPr>
         <p:blipFill>
-          <a:blip xmlns:r="http://schemas.openxmlformats.org/officeDocument/2006/relationships" xmlns:a="http://schemas.openxmlformats.org/drawingml/2006/main" r:embed="R4653c04a026d4b4b"/>
+          <a:blip xmlns:r="http://schemas.openxmlformats.org/officeDocument/2006/relationships" xmlns:a="http://schemas.openxmlformats.org/drawingml/2006/main" r:embed="Ra13c6b10d4d645bc"/>
           <a:stretch xmlns:a="http://schemas.openxmlformats.org/drawingml/2006/main"/>
         </p:blipFill>
         <p:spPr>
@@ -5136,7 +5207,7 @@
           <p:cNvPr id="6" name="">
             <a:extLst xmlns:a="http://schemas.openxmlformats.org/drawingml/2006/main">
               <a:ext uri="{FF2B5EF4-FFF2-40B4-BE49-F238E27FC236}">
-                <a16:creationId xmlns:a16="http://schemas.microsoft.com/office/drawing/2014/main" id="{C36E20EE-DF3B-44E4-9CE9-9F3602BC06EB}"/>
+                <a16:creationId xmlns:a16="http://schemas.microsoft.com/office/drawing/2014/main" id="{2E1EC3F6-9C50-4ECF-B68F-A54AE40364E8}"/>
               </a:ext>
             </a:extLst>
           </p:cNvPr>
@@ -6478,7 +6549,7 @@
           <p:cNvPr id="6" name="">
             <a:extLst xmlns:a="http://schemas.openxmlformats.org/drawingml/2006/main">
               <a:ext uri="{FF2B5EF4-FFF2-40B4-BE49-F238E27FC236}">
-                <a16:creationId xmlns:a16="http://schemas.microsoft.com/office/drawing/2014/main" id="{EF942DA1-001F-4132-962F-73A7A8813336}"/>
+                <a16:creationId xmlns:a16="http://schemas.microsoft.com/office/drawing/2014/main" id="{74362BA3-770C-4FDF-BC42-55DE7CB314A3}"/>
               </a:ext>
             </a:extLst>
           </p:cNvPr>
@@ -8084,7 +8155,7 @@
           <p:cNvPr id="6" name="">
             <a:extLst xmlns:a="http://schemas.openxmlformats.org/drawingml/2006/main">
               <a:ext uri="{FF2B5EF4-FFF2-40B4-BE49-F238E27FC236}">
-                <a16:creationId xmlns:a16="http://schemas.microsoft.com/office/drawing/2014/main" id="{E95A7F40-B4A3-4D5F-80AD-33EA903A3394}"/>
+                <a16:creationId xmlns:a16="http://schemas.microsoft.com/office/drawing/2014/main" id="{C1BB52B1-9A28-4598-B098-BE5F67A7C1B9}"/>
               </a:ext>
             </a:extLst>
           </p:cNvPr>
@@ -9400,7 +9471,7 @@
           <p:cNvPr id="24" name="">
             <a:extLst xmlns:a="http://schemas.openxmlformats.org/drawingml/2006/main">
               <a:ext uri="{FF2B5EF4-FFF2-40B4-BE49-F238E27FC236}">
-                <a16:creationId xmlns:a16="http://schemas.microsoft.com/office/drawing/2014/main" id="{6A02C65D-D26B-4A66-86E0-67288FC6946E}"/>
+                <a16:creationId xmlns:a16="http://schemas.microsoft.com/office/drawing/2014/main" id="{A0D74D86-012D-47AE-BA23-8FB02CEB7989}"/>
               </a:ext>
             </a:extLst>
           </p:cNvPr>
@@ -9434,7 +9505,7 @@
           <p:cNvPr id="23" name="">
             <a:extLst xmlns:a="http://schemas.openxmlformats.org/drawingml/2006/main">
               <a:ext uri="{FF2B5EF4-FFF2-40B4-BE49-F238E27FC236}">
-                <a16:creationId xmlns:a16="http://schemas.microsoft.com/office/drawing/2014/main" id="{2936B189-CAC3-4FE1-A710-FDBDA36C2BF3}"/>
+                <a16:creationId xmlns:a16="http://schemas.microsoft.com/office/drawing/2014/main" id="{84217B79-A9AB-440C-9FA4-627B872D2D5F}"/>
               </a:ext>
             </a:extLst>
           </p:cNvPr>
@@ -9468,7 +9539,7 @@
           <p:cNvPr id="16" name="">
             <a:extLst xmlns:a="http://schemas.openxmlformats.org/drawingml/2006/main">
               <a:ext uri="{FF2B5EF4-FFF2-40B4-BE49-F238E27FC236}">
-                <a16:creationId xmlns:a16="http://schemas.microsoft.com/office/drawing/2014/main" id="{AEECC28D-6447-470B-B707-89C4BFAF1A4C}"/>
+                <a16:creationId xmlns:a16="http://schemas.microsoft.com/office/drawing/2014/main" id="{1632FEF6-D568-4132-9752-D06F7C2EF18B}"/>
               </a:ext>
             </a:extLst>
           </p:cNvPr>
@@ -9499,7 +9570,7 @@
           <p:cNvPr id="15" name="">
             <a:extLst xmlns:a="http://schemas.openxmlformats.org/drawingml/2006/main">
               <a:ext uri="{FF2B5EF4-FFF2-40B4-BE49-F238E27FC236}">
-                <a16:creationId xmlns:a16="http://schemas.microsoft.com/office/drawing/2014/main" id="{1A282199-352B-4915-A524-25FD6D700AB9}"/>
+                <a16:creationId xmlns:a16="http://schemas.microsoft.com/office/drawing/2014/main" id="{86C0AA4E-E5F5-44D5-B2A3-4574DA590623}"/>
               </a:ext>
             </a:extLst>
           </p:cNvPr>
@@ -11271,7 +11342,7 @@
           <p:cNvPr id="6" name="">
             <a:extLst xmlns:a="http://schemas.openxmlformats.org/drawingml/2006/main">
               <a:ext uri="{FF2B5EF4-FFF2-40B4-BE49-F238E27FC236}">
-                <a16:creationId xmlns:a16="http://schemas.microsoft.com/office/drawing/2014/main" id="{E7822096-AE91-4B62-B46C-8A6B60093CE7}"/>
+                <a16:creationId xmlns:a16="http://schemas.microsoft.com/office/drawing/2014/main" id="{2A0D4C43-40D8-4EF2-9A6E-3FE43FE85318}"/>
               </a:ext>
             </a:extLst>
           </p:cNvPr>
@@ -13243,7 +13314,7 @@
           <p:cNvPr id="6" name="">
             <a:extLst xmlns:a="http://schemas.openxmlformats.org/drawingml/2006/main">
               <a:ext uri="{FF2B5EF4-FFF2-40B4-BE49-F238E27FC236}">
-                <a16:creationId xmlns:a16="http://schemas.microsoft.com/office/drawing/2014/main" id="{08E8D36A-A3F4-42C1-AF1E-244A6BF7C93E}"/>
+                <a16:creationId xmlns:a16="http://schemas.microsoft.com/office/drawing/2014/main" id="{EB4A7888-C1A8-4BC2-83AE-5C2C37BF324E}"/>
               </a:ext>
             </a:extLst>
           </p:cNvPr>
@@ -15193,7 +15264,7 @@
           <p:cNvPr id="6" name="">
             <a:extLst xmlns:a="http://schemas.openxmlformats.org/drawingml/2006/main">
               <a:ext uri="{FF2B5EF4-FFF2-40B4-BE49-F238E27FC236}">
-                <a16:creationId xmlns:a16="http://schemas.microsoft.com/office/drawing/2014/main" id="{9FFDE19A-1737-4325-9F56-620B0FDFAE09}"/>
+                <a16:creationId xmlns:a16="http://schemas.microsoft.com/office/drawing/2014/main" id="{46C7DCB6-4D67-4100-8884-406AA089803E}"/>
               </a:ext>
             </a:extLst>
           </p:cNvPr>
@@ -16408,6 +16479,1145 @@
 </file>
 
 <file path=ppt/slides/slide17.xml><?xml version="1.0" encoding="utf-8"?>
+<p:sld xmlns:p="http://schemas.openxmlformats.org/presentationml/2006/main">
+  <p:cSld>
+    <p:bg>
+      <p:bgPr>
+        <a:solidFill xmlns:a="http://schemas.openxmlformats.org/drawingml/2006/main">
+          <a:srgbClr val="FFFFFF"/>
+        </a:solidFill>
+      </p:bgPr>
+    </p:bg>
+    <p:spTree>
+      <p:nvGrpSpPr>
+        <p:cNvPr id="1" name=""/>
+        <p:cNvGrpSpPr/>
+        <p:nvPr/>
+      </p:nvGrpSpPr>
+      <p:grpSpPr>
+        <a:xfrm xmlns:a="http://schemas.openxmlformats.org/drawingml/2006/main"/>
+      </p:grpSpPr>
+      <p:sp>
+        <p:nvSpPr>
+          <p:cNvPr id="17" name="What the experiments establish">
+            <a:extLst xmlns:a="http://schemas.openxmlformats.org/drawingml/2006/main">
+              <a:ext uri="{FF2B5EF4-FFF2-40B4-BE49-F238E27FC236}">
+                <a16:creationId xmlns:a16="http://schemas.microsoft.com/office/drawing/2014/main" id="{149B7929-CD8A-4D2E-9620-FEAAD5CD2802}"/>
+              </a:ext>
+            </a:extLst>
+          </p:cNvPr>
+          <p:cNvSpPr>
+            <a:spLocks xmlns:a="http://schemas.openxmlformats.org/drawingml/2006/main" noGrp="1"/>
+          </p:cNvSpPr>
+          <p:nvPr/>
+        </p:nvSpPr>
+        <p:spPr>
+          <a:xfrm xmlns:a="http://schemas.openxmlformats.org/drawingml/2006/main">
+            <a:off x="571500" y="285750"/>
+            <a:ext cx="10953750" cy="619125"/>
+          </a:xfrm>
+          <a:prstGeom xmlns:a="http://schemas.openxmlformats.org/drawingml/2006/main" prst="rect">
+            <a:avLst/>
+          </a:prstGeom>
+          <a:noFill xmlns:a="http://schemas.openxmlformats.org/drawingml/2006/main"/>
+          <a:ln xmlns:a="http://schemas.openxmlformats.org/drawingml/2006/main" w="0">
+            <a:noFill/>
+          </a:ln>
+        </p:spPr>
+        <p:txBody>
+          <a:bodyPr xmlns:a="http://schemas.openxmlformats.org/drawingml/2006/main" wrap="square" lIns="0" tIns="0" rIns="0" bIns="0" anchor="t">
+            <a:noAutofit/>
+          </a:bodyPr>
+          <a:lstStyle xmlns:a="http://schemas.openxmlformats.org/drawingml/2006/main">
+            <a:defPPr algn="l">
+              <a:defRPr sz="3075" b="1">
+                <a:solidFill>
+                  <a:srgbClr val="061747"/>
+                </a:solidFill>
+                <a:latin typeface="Nimbus Sans"/>
+                <a:ea typeface="Nimbus Sans"/>
+                <a:cs typeface="Nimbus Sans"/>
+              </a:defRPr>
+            </a:defPPr>
+          </a:lstStyle>
+          <a:p xmlns:a="http://schemas.openxmlformats.org/drawingml/2006/main">
+            <a:pPr algn="l">
+              <a:buNone/>
+              <a:defRPr sz="3075" b="1">
+                <a:solidFill>
+                  <a:srgbClr val="061747"/>
+                </a:solidFill>
+                <a:latin typeface="Nimbus Sans"/>
+                <a:ea typeface="Nimbus Sans"/>
+                <a:cs typeface="Nimbus Sans"/>
+              </a:defRPr>
+            </a:pPr>
+            <a:r>
+              <a:rPr sz="3075" b="1">
+                <a:solidFill>
+                  <a:srgbClr val="061747"/>
+                </a:solidFill>
+                <a:latin typeface="Nimbus Sans"/>
+                <a:ea typeface="Nimbus Sans"/>
+                <a:cs typeface="Nimbus Sans"/>
+              </a:rPr>
+              <a:t>Business applications and guardrails</a:t>
+            </a:r>
+          </a:p>
+        </p:txBody>
+      </p:sp>
+      <p:sp>
+        <p:nvSpPr>
+          <p:cNvPr id="2" name="Useful diagnostics, with limited evidence of individual predicti">
+            <a:extLst xmlns:a="http://schemas.openxmlformats.org/drawingml/2006/main">
+              <a:ext uri="{FF2B5EF4-FFF2-40B4-BE49-F238E27FC236}">
+                <a16:creationId xmlns:a16="http://schemas.microsoft.com/office/drawing/2014/main" id="{C8833D58-218A-4737-A8B8-81B0ADF639A0}"/>
+              </a:ext>
+            </a:extLst>
+          </p:cNvPr>
+          <p:cNvSpPr>
+            <a:spLocks xmlns:a="http://schemas.openxmlformats.org/drawingml/2006/main" noGrp="1"/>
+          </p:cNvSpPr>
+          <p:nvPr/>
+        </p:nvSpPr>
+        <p:spPr>
+          <a:xfrm xmlns:a="http://schemas.openxmlformats.org/drawingml/2006/main">
+            <a:off x="590550" y="914400"/>
+            <a:ext cx="11001375" cy="428625"/>
+          </a:xfrm>
+          <a:prstGeom xmlns:a="http://schemas.openxmlformats.org/drawingml/2006/main" prst="rect">
+            <a:avLst/>
+          </a:prstGeom>
+          <a:noFill xmlns:a="http://schemas.openxmlformats.org/drawingml/2006/main"/>
+          <a:ln xmlns:a="http://schemas.openxmlformats.org/drawingml/2006/main" w="0">
+            <a:noFill/>
+          </a:ln>
+        </p:spPr>
+        <p:txBody>
+          <a:bodyPr xmlns:a="http://schemas.openxmlformats.org/drawingml/2006/main" wrap="square" lIns="0" tIns="0" rIns="0" bIns="0" anchor="t">
+            <a:noAutofit/>
+          </a:bodyPr>
+          <a:lstStyle xmlns:a="http://schemas.openxmlformats.org/drawingml/2006/main">
+            <a:defPPr algn="l">
+              <a:defRPr sz="1500" b="0">
+                <a:solidFill>
+                  <a:srgbClr val="637B9C"/>
+                </a:solidFill>
+                <a:latin typeface="Nimbus Sans"/>
+                <a:ea typeface="Nimbus Sans"/>
+                <a:cs typeface="Nimbus Sans"/>
+              </a:defRPr>
+            </a:defPPr>
+          </a:lstStyle>
+          <a:p xmlns:a="http://schemas.openxmlformats.org/drawingml/2006/main">
+            <a:pPr algn="l">
+              <a:buNone/>
+              <a:defRPr sz="1500" b="0">
+                <a:solidFill>
+                  <a:srgbClr val="637B9C"/>
+                </a:solidFill>
+                <a:latin typeface="Nimbus Sans"/>
+                <a:ea typeface="Nimbus Sans"/>
+                <a:cs typeface="Nimbus Sans"/>
+              </a:defRPr>
+            </a:pPr>
+            <a:r>
+              <a:rPr sz="1500" b="0">
+                <a:solidFill>
+                  <a:srgbClr val="637B9C"/>
+                </a:solidFill>
+                <a:latin typeface="Nimbus Sans"/>
+                <a:ea typeface="Nimbus Sans"/>
+                <a:cs typeface="Nimbus Sans"/>
+              </a:rPr>
+              <a:t>Proposed uses after validation — current results support exploratory research only</a:t>
+            </a:r>
+          </a:p>
+        </p:txBody>
+      </p:sp>
+      <p:sp>
+        <p:nvSpPr>
+          <p:cNvPr id="3" name="">
+            <a:extLst xmlns:a="http://schemas.openxmlformats.org/drawingml/2006/main">
+              <a:ext uri="{FF2B5EF4-FFF2-40B4-BE49-F238E27FC236}">
+                <a16:creationId xmlns:a16="http://schemas.microsoft.com/office/drawing/2014/main" id="{7122C885-A359-45F8-AE6F-8372B0D5803D}"/>
+              </a:ext>
+            </a:extLst>
+          </p:cNvPr>
+          <p:cNvSpPr>
+            <a:spLocks xmlns:a="http://schemas.openxmlformats.org/drawingml/2006/main" noGrp="1"/>
+          </p:cNvSpPr>
+          <p:nvPr/>
+        </p:nvSpPr>
+        <p:spPr>
+          <a:xfrm xmlns:a="http://schemas.openxmlformats.org/drawingml/2006/main">
+            <a:off x="571500" y="6229350"/>
+            <a:ext cx="11049000" cy="0"/>
+          </a:xfrm>
+          <a:prstGeom xmlns:a="http://schemas.openxmlformats.org/drawingml/2006/main" prst="line">
+            <a:avLst/>
+          </a:prstGeom>
+          <a:noFill xmlns:a="http://schemas.openxmlformats.org/drawingml/2006/main"/>
+          <a:ln xmlns:a="http://schemas.openxmlformats.org/drawingml/2006/main" w="9525">
+            <a:solidFill>
+              <a:srgbClr val="DBE8F4"/>
+            </a:solidFill>
+          </a:ln>
+        </p:spPr>
+      </p:sp>
+      <p:sp>
+        <p:nvSpPr>
+          <p:cNvPr id="4" name="Every score shown is development validation. The final 309-perso">
+            <a:extLst xmlns:a="http://schemas.openxmlformats.org/drawingml/2006/main">
+              <a:ext uri="{FF2B5EF4-FFF2-40B4-BE49-F238E27FC236}">
+                <a16:creationId xmlns:a16="http://schemas.microsoft.com/office/drawing/2014/main" id="{15BCA858-33FE-4AA7-BDE7-1EB46553CB5E}"/>
+              </a:ext>
+            </a:extLst>
+          </p:cNvPr>
+          <p:cNvSpPr>
+            <a:spLocks xmlns:a="http://schemas.openxmlformats.org/drawingml/2006/main" noGrp="1"/>
+          </p:cNvSpPr>
+          <p:nvPr/>
+        </p:nvSpPr>
+        <p:spPr>
+          <a:xfrm xmlns:a="http://schemas.openxmlformats.org/drawingml/2006/main">
+            <a:off x="590550" y="6362700"/>
+            <a:ext cx="10477500" cy="295275"/>
+          </a:xfrm>
+          <a:prstGeom xmlns:a="http://schemas.openxmlformats.org/drawingml/2006/main" prst="rect">
+            <a:avLst/>
+          </a:prstGeom>
+          <a:noFill xmlns:a="http://schemas.openxmlformats.org/drawingml/2006/main"/>
+          <a:ln xmlns:a="http://schemas.openxmlformats.org/drawingml/2006/main" w="0">
+            <a:noFill/>
+          </a:ln>
+        </p:spPr>
+        <p:txBody>
+          <a:bodyPr xmlns:a="http://schemas.openxmlformats.org/drawingml/2006/main" wrap="square" lIns="0" tIns="0" rIns="0" bIns="0" anchor="t">
+            <a:noAutofit/>
+          </a:bodyPr>
+          <a:lstStyle xmlns:a="http://schemas.openxmlformats.org/drawingml/2006/main">
+            <a:defPPr algn="l">
+              <a:defRPr sz="1050" b="0">
+                <a:solidFill>
+                  <a:srgbClr val="637B9C"/>
+                </a:solidFill>
+                <a:latin typeface="Nimbus Sans"/>
+                <a:ea typeface="Nimbus Sans"/>
+                <a:cs typeface="Nimbus Sans"/>
+              </a:defRPr>
+            </a:defPPr>
+          </a:lstStyle>
+          <a:p xmlns:a="http://schemas.openxmlformats.org/drawingml/2006/main">
+            <a:pPr algn="l">
+              <a:buNone/>
+              <a:defRPr sz="1050" b="0">
+                <a:solidFill>
+                  <a:srgbClr val="637B9C"/>
+                </a:solidFill>
+                <a:latin typeface="Nimbus Sans"/>
+                <a:ea typeface="Nimbus Sans"/>
+                <a:cs typeface="Nimbus Sans"/>
+              </a:defRPr>
+            </a:pPr>
+            <a:r>
+              <a:rPr sz="1050" b="0">
+                <a:solidFill>
+                  <a:srgbClr val="637B9C"/>
+                </a:solidFill>
+                <a:latin typeface="Nimbus Sans"/>
+                <a:ea typeface="Nimbus Sans"/>
+                <a:cs typeface="Nimbus Sans"/>
+              </a:rPr>
+              <a:t>Exploratory POC: reliable individual gains are unproven, and the reserved test set remains unscored.</a:t>
+            </a:r>
+          </a:p>
+        </p:txBody>
+      </p:sp>
+      <p:sp>
+        <p:nvSpPr>
+          <p:cNvPr id="5" name="15">
+            <a:extLst xmlns:a="http://schemas.openxmlformats.org/drawingml/2006/main">
+              <a:ext uri="{FF2B5EF4-FFF2-40B4-BE49-F238E27FC236}">
+                <a16:creationId xmlns:a16="http://schemas.microsoft.com/office/drawing/2014/main" id="{D768BB73-D599-4C2E-817F-9C56D2F2F085}"/>
+              </a:ext>
+            </a:extLst>
+          </p:cNvPr>
+          <p:cNvSpPr>
+            <a:spLocks xmlns:a="http://schemas.openxmlformats.org/drawingml/2006/main" noGrp="1"/>
+          </p:cNvSpPr>
+          <p:nvPr/>
+        </p:nvSpPr>
+        <p:spPr>
+          <a:xfrm xmlns:a="http://schemas.openxmlformats.org/drawingml/2006/main">
+            <a:off x="11182350" y="6372225"/>
+            <a:ext cx="400050" cy="238125"/>
+          </a:xfrm>
+          <a:prstGeom xmlns:a="http://schemas.openxmlformats.org/drawingml/2006/main" prst="rect">
+            <a:avLst/>
+          </a:prstGeom>
+          <a:noFill xmlns:a="http://schemas.openxmlformats.org/drawingml/2006/main"/>
+          <a:ln xmlns:a="http://schemas.openxmlformats.org/drawingml/2006/main" w="0">
+            <a:noFill/>
+          </a:ln>
+        </p:spPr>
+        <p:txBody>
+          <a:bodyPr xmlns:a="http://schemas.openxmlformats.org/drawingml/2006/main" wrap="square" lIns="0" tIns="0" rIns="0" bIns="0" anchor="t">
+            <a:noAutofit/>
+          </a:bodyPr>
+          <a:lstStyle xmlns:a="http://schemas.openxmlformats.org/drawingml/2006/main">
+            <a:defPPr algn="r">
+              <a:defRPr sz="1125" b="0">
+                <a:solidFill>
+                  <a:srgbClr val="637B9C"/>
+                </a:solidFill>
+                <a:latin typeface="Nimbus Sans"/>
+                <a:ea typeface="Nimbus Sans"/>
+                <a:cs typeface="Nimbus Sans"/>
+              </a:defRPr>
+            </a:defPPr>
+          </a:lstStyle>
+          <a:p xmlns:a="http://schemas.openxmlformats.org/drawingml/2006/main">
+            <a:pPr algn="r">
+              <a:buNone/>
+              <a:defRPr sz="1125" b="0">
+                <a:solidFill>
+                  <a:srgbClr val="637B9C"/>
+                </a:solidFill>
+                <a:latin typeface="Nimbus Sans"/>
+                <a:ea typeface="Nimbus Sans"/>
+                <a:cs typeface="Nimbus Sans"/>
+              </a:defRPr>
+            </a:pPr>
+            <a:r>
+              <a:rPr sz="1125" b="0">
+                <a:solidFill>
+                  <a:srgbClr val="637B9C"/>
+                </a:solidFill>
+                <a:latin typeface="Nimbus Sans"/>
+                <a:ea typeface="Nimbus Sans"/>
+                <a:cs typeface="Nimbus Sans"/>
+              </a:rPr>
+              <a:t>17</a:t>
+            </a:r>
+          </a:p>
+        </p:txBody>
+      </p:sp>
+      <p:sp>
+        <p:nvSpPr>
+          <p:cNvPr id="6" name="content-surface">
+            <a:extLst xmlns:a="http://schemas.openxmlformats.org/drawingml/2006/main">
+              <a:ext uri="{FF2B5EF4-FFF2-40B4-BE49-F238E27FC236}">
+                <a16:creationId xmlns:a16="http://schemas.microsoft.com/office/drawing/2014/main" id="{225E0A43-9D1C-42AF-A0FE-823B3A332308}"/>
+              </a:ext>
+            </a:extLst>
+          </p:cNvPr>
+          <p:cNvSpPr>
+            <a:spLocks xmlns:a="http://schemas.openxmlformats.org/drawingml/2006/main" noGrp="1"/>
+          </p:cNvSpPr>
+          <p:nvPr/>
+        </p:nvSpPr>
+        <p:spPr>
+          <a:xfrm xmlns:a="http://schemas.openxmlformats.org/drawingml/2006/main">
+            <a:off x="609600" y="1676400"/>
+            <a:ext cx="3495675" cy="2428875"/>
+          </a:xfrm>
+          <a:prstGeom xmlns:a="http://schemas.openxmlformats.org/drawingml/2006/main" prst="roundRect">
+            <a:avLst>
+              <a:gd name="adj" fmla="val 4308"/>
+            </a:avLst>
+          </a:prstGeom>
+          <a:solidFill xmlns:a="http://schemas.openxmlformats.org/drawingml/2006/main">
+            <a:srgbClr val="EFF7FE"/>
+          </a:solidFill>
+          <a:ln xmlns:a="http://schemas.openxmlformats.org/drawingml/2006/main" w="9525">
+            <a:solidFill>
+              <a:srgbClr val="DBE8F4"/>
+            </a:solidFill>
+          </a:ln>
+        </p:spPr>
+        <p:style>
+          <a:lnRef xmlns:a="http://schemas.openxmlformats.org/drawingml/2006/main" idx="0"/>
+          <a:fillRef xmlns:a="http://schemas.openxmlformats.org/drawingml/2006/main" idx="0"/>
+          <a:effectRef xmlns:a="http://schemas.openxmlformats.org/drawingml/2006/main" idx="10"/>
+          <a:fontRef xmlns:a="http://schemas.openxmlformats.org/drawingml/2006/main" idx="major"/>
+        </p:style>
+      </p:sp>
+      <p:sp>
+        <p:nvSpPr>
+          <p:cNvPr id="7" name="Fine-tuning">
+            <a:extLst xmlns:a="http://schemas.openxmlformats.org/drawingml/2006/main">
+              <a:ext uri="{FF2B5EF4-FFF2-40B4-BE49-F238E27FC236}">
+                <a16:creationId xmlns:a16="http://schemas.microsoft.com/office/drawing/2014/main" id="{D8B41A92-40FE-4C8C-8600-FB13559FD4FB}"/>
+              </a:ext>
+            </a:extLst>
+          </p:cNvPr>
+          <p:cNvSpPr>
+            <a:spLocks xmlns:a="http://schemas.openxmlformats.org/drawingml/2006/main" noGrp="1"/>
+          </p:cNvSpPr>
+          <p:nvPr/>
+        </p:nvSpPr>
+        <p:spPr>
+          <a:xfrm xmlns:a="http://schemas.openxmlformats.org/drawingml/2006/main">
+            <a:off x="838200" y="1914525"/>
+            <a:ext cx="3057525" cy="495300"/>
+          </a:xfrm>
+          <a:prstGeom xmlns:a="http://schemas.openxmlformats.org/drawingml/2006/main" prst="rect">
+            <a:avLst/>
+          </a:prstGeom>
+          <a:noFill xmlns:a="http://schemas.openxmlformats.org/drawingml/2006/main"/>
+          <a:ln xmlns:a="http://schemas.openxmlformats.org/drawingml/2006/main" w="0">
+            <a:noFill/>
+          </a:ln>
+        </p:spPr>
+        <p:txBody>
+          <a:bodyPr xmlns:a="http://schemas.openxmlformats.org/drawingml/2006/main" wrap="square" lIns="0" tIns="0" rIns="0" bIns="0" anchor="t">
+            <a:noAutofit/>
+          </a:bodyPr>
+          <a:lstStyle xmlns:a="http://schemas.openxmlformats.org/drawingml/2006/main">
+            <a:defPPr algn="l">
+              <a:defRPr sz="2175" b="1">
+                <a:solidFill>
+                  <a:srgbClr val="1673FF"/>
+                </a:solidFill>
+                <a:latin typeface="Nimbus Sans"/>
+                <a:ea typeface="Nimbus Sans"/>
+                <a:cs typeface="Nimbus Sans"/>
+              </a:defRPr>
+            </a:defPPr>
+          </a:lstStyle>
+          <a:p xmlns:a="http://schemas.openxmlformats.org/drawingml/2006/main">
+            <a:pPr algn="l">
+              <a:buNone/>
+              <a:defRPr sz="2175" b="1">
+                <a:solidFill>
+                  <a:srgbClr val="1673FF"/>
+                </a:solidFill>
+                <a:latin typeface="Nimbus Sans"/>
+                <a:ea typeface="Nimbus Sans"/>
+                <a:cs typeface="Nimbus Sans"/>
+              </a:defRPr>
+            </a:pPr>
+            <a:r>
+              <a:rPr sz="2175" b="1">
+                <a:solidFill>
+                  <a:srgbClr val="1673FF"/>
+                </a:solidFill>
+                <a:latin typeface="Nimbus Sans"/>
+                <a:ea typeface="Nimbus Sans"/>
+                <a:cs typeface="Nimbus Sans"/>
+              </a:rPr>
+              <a:t>Retail research teams</a:t>
+            </a:r>
+          </a:p>
+        </p:txBody>
+      </p:sp>
+      <p:sp>
+        <p:nvSpPr>
+          <p:cNvPr id="8" name="Full training reaches the majority pattern in the nine-question ">
+            <a:extLst xmlns:a="http://schemas.openxmlformats.org/drawingml/2006/main">
+              <a:ext uri="{FF2B5EF4-FFF2-40B4-BE49-F238E27FC236}">
+                <a16:creationId xmlns:a16="http://schemas.microsoft.com/office/drawing/2014/main" id="{63583820-1AE4-40B2-899C-F79D291780BB}"/>
+              </a:ext>
+            </a:extLst>
+          </p:cNvPr>
+          <p:cNvSpPr>
+            <a:spLocks xmlns:a="http://schemas.openxmlformats.org/drawingml/2006/main" noGrp="1"/>
+          </p:cNvSpPr>
+          <p:nvPr/>
+        </p:nvSpPr>
+        <p:spPr>
+          <a:xfrm xmlns:a="http://schemas.openxmlformats.org/drawingml/2006/main">
+            <a:off x="838200" y="2447925"/>
+            <a:ext cx="3038475" cy="1476375"/>
+          </a:xfrm>
+          <a:prstGeom xmlns:a="http://schemas.openxmlformats.org/drawingml/2006/main" prst="rect">
+            <a:avLst/>
+          </a:prstGeom>
+          <a:noFill xmlns:a="http://schemas.openxmlformats.org/drawingml/2006/main"/>
+          <a:ln xmlns:a="http://schemas.openxmlformats.org/drawingml/2006/main" w="0">
+            <a:noFill/>
+          </a:ln>
+        </p:spPr>
+        <p:txBody>
+          <a:bodyPr xmlns:a="http://schemas.openxmlformats.org/drawingml/2006/main" wrap="square" lIns="0" tIns="0" rIns="0" bIns="0" anchor="t">
+            <a:noAutofit/>
+          </a:bodyPr>
+          <a:lstStyle xmlns:a="http://schemas.openxmlformats.org/drawingml/2006/main">
+            <a:defPPr algn="l">
+              <a:defRPr sz="1875" b="0">
+                <a:solidFill>
+                  <a:srgbClr val="061747"/>
+                </a:solidFill>
+                <a:latin typeface="Nimbus Sans"/>
+                <a:ea typeface="Nimbus Sans"/>
+                <a:cs typeface="Nimbus Sans"/>
+              </a:defRPr>
+            </a:defPPr>
+          </a:lstStyle>
+          <a:p xmlns:a="http://schemas.openxmlformats.org/drawingml/2006/main">
+            <a:pPr algn="l">
+              <a:buNone/>
+              <a:defRPr sz="1875" b="0">
+                <a:solidFill>
+                  <a:srgbClr val="061747"/>
+                </a:solidFill>
+                <a:latin typeface="Nimbus Sans"/>
+                <a:ea typeface="Nimbus Sans"/>
+                <a:cs typeface="Nimbus Sans"/>
+              </a:defRPr>
+            </a:pPr>
+            <a:r>
+              <a:rPr sz="1875" b="0">
+                <a:solidFill>
+                  <a:srgbClr val="061747"/>
+                </a:solidFill>
+                <a:latin typeface="Nimbus Sans"/>
+                <a:ea typeface="Nimbus Sans"/>
+                <a:cs typeface="Nimbus Sans"/>
+              </a:rPr>
+              <a:t>Screen product–price scenarios at cohort level; choose hypotheses for real customer surveys.</a:t>
+            </a:r>
+          </a:p>
+        </p:txBody>
+      </p:sp>
+      <p:sp>
+        <p:nvSpPr>
+          <p:cNvPr id="9" name="content-surface">
+            <a:extLst xmlns:a="http://schemas.openxmlformats.org/drawingml/2006/main">
+              <a:ext uri="{FF2B5EF4-FFF2-40B4-BE49-F238E27FC236}">
+                <a16:creationId xmlns:a16="http://schemas.microsoft.com/office/drawing/2014/main" id="{97F2CC96-3F34-4993-9C39-9877AB4F270D}"/>
+              </a:ext>
+            </a:extLst>
+          </p:cNvPr>
+          <p:cNvSpPr>
+            <a:spLocks xmlns:a="http://schemas.openxmlformats.org/drawingml/2006/main" noGrp="1"/>
+          </p:cNvSpPr>
+          <p:nvPr/>
+        </p:nvSpPr>
+        <p:spPr>
+          <a:xfrm xmlns:a="http://schemas.openxmlformats.org/drawingml/2006/main">
+            <a:off x="4400550" y="1676400"/>
+            <a:ext cx="3495675" cy="2428875"/>
+          </a:xfrm>
+          <a:prstGeom xmlns:a="http://schemas.openxmlformats.org/drawingml/2006/main" prst="roundRect">
+            <a:avLst>
+              <a:gd name="adj" fmla="val 4308"/>
+            </a:avLst>
+          </a:prstGeom>
+          <a:solidFill xmlns:a="http://schemas.openxmlformats.org/drawingml/2006/main">
+            <a:srgbClr val="EFFBFA"/>
+          </a:solidFill>
+          <a:ln xmlns:a="http://schemas.openxmlformats.org/drawingml/2006/main" w="9525">
+            <a:solidFill>
+              <a:srgbClr val="DBE8F4"/>
+            </a:solidFill>
+          </a:ln>
+        </p:spPr>
+        <p:style>
+          <a:lnRef xmlns:a="http://schemas.openxmlformats.org/drawingml/2006/main" idx="0"/>
+          <a:fillRef xmlns:a="http://schemas.openxmlformats.org/drawingml/2006/main" idx="0"/>
+          <a:effectRef xmlns:a="http://schemas.openxmlformats.org/drawingml/2006/main" idx="10"/>
+          <a:fontRef xmlns:a="http://schemas.openxmlformats.org/drawingml/2006/main" idx="major"/>
+        </p:style>
+      </p:sp>
+      <p:sp>
+        <p:nvSpPr>
+          <p:cNvPr id="10" name="Personalization">
+            <a:extLst xmlns:a="http://schemas.openxmlformats.org/drawingml/2006/main">
+              <a:ext uri="{FF2B5EF4-FFF2-40B4-BE49-F238E27FC236}">
+                <a16:creationId xmlns:a16="http://schemas.microsoft.com/office/drawing/2014/main" id="{5CEC1E67-5AC5-4145-A9FA-DDBC60716A03}"/>
+              </a:ext>
+            </a:extLst>
+          </p:cNvPr>
+          <p:cNvSpPr>
+            <a:spLocks xmlns:a="http://schemas.openxmlformats.org/drawingml/2006/main" noGrp="1"/>
+          </p:cNvSpPr>
+          <p:nvPr/>
+        </p:nvSpPr>
+        <p:spPr>
+          <a:xfrm xmlns:a="http://schemas.openxmlformats.org/drawingml/2006/main">
+            <a:off x="4629150" y="1914525"/>
+            <a:ext cx="3057525" cy="495300"/>
+          </a:xfrm>
+          <a:prstGeom xmlns:a="http://schemas.openxmlformats.org/drawingml/2006/main" prst="rect">
+            <a:avLst/>
+          </a:prstGeom>
+          <a:noFill xmlns:a="http://schemas.openxmlformats.org/drawingml/2006/main"/>
+          <a:ln xmlns:a="http://schemas.openxmlformats.org/drawingml/2006/main" w="0">
+            <a:noFill/>
+          </a:ln>
+        </p:spPr>
+        <p:txBody>
+          <a:bodyPr xmlns:a="http://schemas.openxmlformats.org/drawingml/2006/main" wrap="square" lIns="0" tIns="0" rIns="0" bIns="0" anchor="t">
+            <a:noAutofit/>
+          </a:bodyPr>
+          <a:lstStyle xmlns:a="http://schemas.openxmlformats.org/drawingml/2006/main">
+            <a:defPPr algn="l">
+              <a:defRPr sz="2175" b="1">
+                <a:solidFill>
+                  <a:srgbClr val="009E9A"/>
+                </a:solidFill>
+                <a:latin typeface="Nimbus Sans"/>
+                <a:ea typeface="Nimbus Sans"/>
+                <a:cs typeface="Nimbus Sans"/>
+              </a:defRPr>
+            </a:defPPr>
+          </a:lstStyle>
+          <a:p xmlns:a="http://schemas.openxmlformats.org/drawingml/2006/main">
+            <a:pPr algn="l">
+              <a:buNone/>
+              <a:defRPr sz="2175" b="1">
+                <a:solidFill>
+                  <a:srgbClr val="009E9A"/>
+                </a:solidFill>
+                <a:latin typeface="Nimbus Sans"/>
+                <a:ea typeface="Nimbus Sans"/>
+                <a:cs typeface="Nimbus Sans"/>
+              </a:defRPr>
+            </a:pPr>
+            <a:r>
+              <a:rPr sz="2175" b="1">
+                <a:solidFill>
+                  <a:srgbClr val="009E9A"/>
+                </a:solidFill>
+                <a:latin typeface="Nimbus Sans"/>
+                <a:ea typeface="Nimbus Sans"/>
+                <a:cs typeface="Nimbus Sans"/>
+              </a:rPr>
+              <a:t>Product / UX teams</a:t>
+            </a:r>
+          </a:p>
+        </p:txBody>
+      </p:sp>
+      <p:sp>
+        <p:nvSpPr>
+          <p:cNvPr id="11" name="Removing or shuffling A changes predictions and several scores. ">
+            <a:extLst xmlns:a="http://schemas.openxmlformats.org/drawingml/2006/main">
+              <a:ext uri="{FF2B5EF4-FFF2-40B4-BE49-F238E27FC236}">
+                <a16:creationId xmlns:a16="http://schemas.microsoft.com/office/drawing/2014/main" id="{74DB6B70-845F-4F5E-AFBC-192B3F53C94D}"/>
+              </a:ext>
+            </a:extLst>
+          </p:cNvPr>
+          <p:cNvSpPr>
+            <a:spLocks xmlns:a="http://schemas.openxmlformats.org/drawingml/2006/main" noGrp="1"/>
+          </p:cNvSpPr>
+          <p:nvPr/>
+        </p:nvSpPr>
+        <p:spPr>
+          <a:xfrm xmlns:a="http://schemas.openxmlformats.org/drawingml/2006/main">
+            <a:off x="4629150" y="2447925"/>
+            <a:ext cx="3038475" cy="1476375"/>
+          </a:xfrm>
+          <a:prstGeom xmlns:a="http://schemas.openxmlformats.org/drawingml/2006/main" prst="rect">
+            <a:avLst/>
+          </a:prstGeom>
+          <a:noFill xmlns:a="http://schemas.openxmlformats.org/drawingml/2006/main"/>
+          <a:ln xmlns:a="http://schemas.openxmlformats.org/drawingml/2006/main" w="0">
+            <a:noFill/>
+          </a:ln>
+        </p:spPr>
+        <p:txBody>
+          <a:bodyPr xmlns:a="http://schemas.openxmlformats.org/drawingml/2006/main" wrap="square" lIns="0" tIns="0" rIns="0" bIns="0" anchor="t">
+            <a:noAutofit/>
+          </a:bodyPr>
+          <a:lstStyle xmlns:a="http://schemas.openxmlformats.org/drawingml/2006/main">
+            <a:defPPr algn="l">
+              <a:defRPr sz="1875" b="0">
+                <a:solidFill>
+                  <a:srgbClr val="061747"/>
+                </a:solidFill>
+                <a:latin typeface="Nimbus Sans"/>
+                <a:ea typeface="Nimbus Sans"/>
+                <a:cs typeface="Nimbus Sans"/>
+              </a:defRPr>
+            </a:defPPr>
+          </a:lstStyle>
+          <a:p xmlns:a="http://schemas.openxmlformats.org/drawingml/2006/main">
+            <a:pPr algn="l">
+              <a:buNone/>
+              <a:defRPr sz="1875" b="0">
+                <a:solidFill>
+                  <a:srgbClr val="061747"/>
+                </a:solidFill>
+                <a:latin typeface="Nimbus Sans"/>
+                <a:ea typeface="Nimbus Sans"/>
+                <a:cs typeface="Nimbus Sans"/>
+              </a:defRPr>
+            </a:pPr>
+            <a:r>
+              <a:rPr sz="1875" b="0">
+                <a:solidFill>
+                  <a:srgbClr val="061747"/>
+                </a:solidFill>
+                <a:latin typeface="Nimbus Sans"/>
+                <a:ea typeface="Nimbus Sans"/>
+                <a:cs typeface="Nimbus Sans"/>
+              </a:rPr>
+              <a:t>Pretest survey concepts and answer options; flag unstable simulated responses for human testing.</a:t>
+            </a:r>
+          </a:p>
+        </p:txBody>
+      </p:sp>
+      <p:sp>
+        <p:nvSpPr>
+          <p:cNvPr id="12" name="content-surface">
+            <a:extLst xmlns:a="http://schemas.openxmlformats.org/drawingml/2006/main">
+              <a:ext uri="{FF2B5EF4-FFF2-40B4-BE49-F238E27FC236}">
+                <a16:creationId xmlns:a16="http://schemas.microsoft.com/office/drawing/2014/main" id="{CD31E729-69D7-44EC-80CB-E230E4E72A7F}"/>
+              </a:ext>
+            </a:extLst>
+          </p:cNvPr>
+          <p:cNvSpPr>
+            <a:spLocks xmlns:a="http://schemas.openxmlformats.org/drawingml/2006/main" noGrp="1"/>
+          </p:cNvSpPr>
+          <p:nvPr/>
+        </p:nvSpPr>
+        <p:spPr>
+          <a:xfrm xmlns:a="http://schemas.openxmlformats.org/drawingml/2006/main">
+            <a:off x="8191500" y="1676400"/>
+            <a:ext cx="3495675" cy="2428875"/>
+          </a:xfrm>
+          <a:prstGeom xmlns:a="http://schemas.openxmlformats.org/drawingml/2006/main" prst="roundRect">
+            <a:avLst>
+              <a:gd name="adj" fmla="val 4308"/>
+            </a:avLst>
+          </a:prstGeom>
+          <a:solidFill xmlns:a="http://schemas.openxmlformats.org/drawingml/2006/main">
+            <a:srgbClr val="F5F3FE"/>
+          </a:solidFill>
+          <a:ln xmlns:a="http://schemas.openxmlformats.org/drawingml/2006/main" w="9525">
+            <a:solidFill>
+              <a:srgbClr val="DBE8F4"/>
+            </a:solidFill>
+          </a:ln>
+        </p:spPr>
+        <p:style>
+          <a:lnRef xmlns:a="http://schemas.openxmlformats.org/drawingml/2006/main" idx="0"/>
+          <a:fillRef xmlns:a="http://schemas.openxmlformats.org/drawingml/2006/main" idx="0"/>
+          <a:effectRef xmlns:a="http://schemas.openxmlformats.org/drawingml/2006/main" idx="10"/>
+          <a:fontRef xmlns:a="http://schemas.openxmlformats.org/drawingml/2006/main" idx="major"/>
+        </p:style>
+      </p:sp>
+      <p:sp>
+        <p:nvSpPr>
+          <p:cNvPr id="13" name="Retrieval">
+            <a:extLst xmlns:a="http://schemas.openxmlformats.org/drawingml/2006/main">
+              <a:ext uri="{FF2B5EF4-FFF2-40B4-BE49-F238E27FC236}">
+                <a16:creationId xmlns:a16="http://schemas.microsoft.com/office/drawing/2014/main" id="{39D130FB-5582-41E5-B8F7-63D527E6250E}"/>
+              </a:ext>
+            </a:extLst>
+          </p:cNvPr>
+          <p:cNvSpPr>
+            <a:spLocks xmlns:a="http://schemas.openxmlformats.org/drawingml/2006/main" noGrp="1"/>
+          </p:cNvSpPr>
+          <p:nvPr/>
+        </p:nvSpPr>
+        <p:spPr>
+          <a:xfrm xmlns:a="http://schemas.openxmlformats.org/drawingml/2006/main">
+            <a:off x="8420100" y="1914525"/>
+            <a:ext cx="3057525" cy="495300"/>
+          </a:xfrm>
+          <a:prstGeom xmlns:a="http://schemas.openxmlformats.org/drawingml/2006/main" prst="rect">
+            <a:avLst/>
+          </a:prstGeom>
+          <a:noFill xmlns:a="http://schemas.openxmlformats.org/drawingml/2006/main"/>
+          <a:ln xmlns:a="http://schemas.openxmlformats.org/drawingml/2006/main" w="0">
+            <a:noFill/>
+          </a:ln>
+        </p:spPr>
+        <p:txBody>
+          <a:bodyPr xmlns:a="http://schemas.openxmlformats.org/drawingml/2006/main" wrap="square" lIns="0" tIns="0" rIns="0" bIns="0" anchor="t">
+            <a:noAutofit/>
+          </a:bodyPr>
+          <a:lstStyle xmlns:a="http://schemas.openxmlformats.org/drawingml/2006/main">
+            <a:defPPr algn="l">
+              <a:defRPr sz="2175" b="1">
+                <a:solidFill>
+                  <a:srgbClr val="8254F5"/>
+                </a:solidFill>
+                <a:latin typeface="Nimbus Sans"/>
+                <a:ea typeface="Nimbus Sans"/>
+                <a:cs typeface="Nimbus Sans"/>
+              </a:defRPr>
+            </a:defPPr>
+          </a:lstStyle>
+          <a:p xmlns:a="http://schemas.openxmlformats.org/drawingml/2006/main">
+            <a:pPr algn="l">
+              <a:buNone/>
+              <a:defRPr sz="2175" b="1">
+                <a:solidFill>
+                  <a:srgbClr val="8254F5"/>
+                </a:solidFill>
+                <a:latin typeface="Nimbus Sans"/>
+                <a:ea typeface="Nimbus Sans"/>
+                <a:cs typeface="Nimbus Sans"/>
+              </a:defRPr>
+            </a:pPr>
+            <a:r>
+              <a:rPr sz="2175" b="1">
+                <a:solidFill>
+                  <a:srgbClr val="8254F5"/>
+                </a:solidFill>
+                <a:latin typeface="Nimbus Sans"/>
+                <a:ea typeface="Nimbus Sans"/>
+                <a:cs typeface="Nimbus Sans"/>
+              </a:rPr>
+              <a:t>Research teams</a:t>
+            </a:r>
+          </a:p>
+        </p:txBody>
+      </p:sp>
+      <p:sp>
+        <p:nvSpPr>
+          <p:cNvPr id="14" name="Selected-answer embeddings help neighbor voting. The small answe">
+            <a:extLst xmlns:a="http://schemas.openxmlformats.org/drawingml/2006/main">
+              <a:ext uri="{FF2B5EF4-FFF2-40B4-BE49-F238E27FC236}">
+                <a16:creationId xmlns:a16="http://schemas.microsoft.com/office/drawing/2014/main" id="{F159D217-30BF-494A-8F6D-58D74C8C4197}"/>
+              </a:ext>
+            </a:extLst>
+          </p:cNvPr>
+          <p:cNvSpPr>
+            <a:spLocks xmlns:a="http://schemas.openxmlformats.org/drawingml/2006/main" noGrp="1"/>
+          </p:cNvSpPr>
+          <p:nvPr/>
+        </p:nvSpPr>
+        <p:spPr>
+          <a:xfrm xmlns:a="http://schemas.openxmlformats.org/drawingml/2006/main">
+            <a:off x="8420100" y="2447925"/>
+            <a:ext cx="3038475" cy="1476375"/>
+          </a:xfrm>
+          <a:prstGeom xmlns:a="http://schemas.openxmlformats.org/drawingml/2006/main" prst="rect">
+            <a:avLst/>
+          </a:prstGeom>
+          <a:noFill xmlns:a="http://schemas.openxmlformats.org/drawingml/2006/main"/>
+          <a:ln xmlns:a="http://schemas.openxmlformats.org/drawingml/2006/main" w="0">
+            <a:noFill/>
+          </a:ln>
+        </p:spPr>
+        <p:txBody>
+          <a:bodyPr xmlns:a="http://schemas.openxmlformats.org/drawingml/2006/main" wrap="square" lIns="0" tIns="0" rIns="0" bIns="0" anchor="t">
+            <a:noAutofit/>
+          </a:bodyPr>
+          <a:lstStyle xmlns:a="http://schemas.openxmlformats.org/drawingml/2006/main">
+            <a:defPPr algn="l">
+              <a:defRPr sz="1875" b="0">
+                <a:solidFill>
+                  <a:srgbClr val="061747"/>
+                </a:solidFill>
+                <a:latin typeface="Nimbus Sans"/>
+                <a:ea typeface="Nimbus Sans"/>
+                <a:cs typeface="Nimbus Sans"/>
+              </a:defRPr>
+            </a:defPPr>
+          </a:lstStyle>
+          <a:p xmlns:a="http://schemas.openxmlformats.org/drawingml/2006/main">
+            <a:pPr algn="l">
+              <a:buNone/>
+              <a:defRPr sz="1875" b="0">
+                <a:solidFill>
+                  <a:srgbClr val="061747"/>
+                </a:solidFill>
+                <a:latin typeface="Nimbus Sans"/>
+                <a:ea typeface="Nimbus Sans"/>
+                <a:cs typeface="Nimbus Sans"/>
+              </a:defRPr>
+            </a:pPr>
+            <a:r>
+              <a:rPr sz="1875" b="0">
+                <a:solidFill>
+                  <a:srgbClr val="061747"/>
+                </a:solidFill>
+                <a:latin typeface="Nimbus Sans"/>
+                <a:ea typeface="Nimbus Sans"/>
+                <a:cs typeface="Nimbus Sans"/>
+              </a:rPr>
+              <a:t>Explore aggregate preference patterns and repeatability; compare profile-based models with simple baselines.</a:t>
+            </a:r>
+          </a:p>
+        </p:txBody>
+      </p:sp>
+      <p:sp>
+        <p:nvSpPr>
+          <p:cNvPr id="15" name="Next step">
+            <a:extLst xmlns:a="http://schemas.openxmlformats.org/drawingml/2006/main">
+              <a:ext uri="{FF2B5EF4-FFF2-40B4-BE49-F238E27FC236}">
+                <a16:creationId xmlns:a16="http://schemas.microsoft.com/office/drawing/2014/main" id="{F9DEA30A-5E79-4A5F-8899-342E9329AA57}"/>
+              </a:ext>
+            </a:extLst>
+          </p:cNvPr>
+          <p:cNvSpPr>
+            <a:spLocks xmlns:a="http://schemas.openxmlformats.org/drawingml/2006/main" noGrp="1"/>
+          </p:cNvSpPr>
+          <p:nvPr/>
+        </p:nvSpPr>
+        <p:spPr>
+          <a:xfrm xmlns:a="http://schemas.openxmlformats.org/drawingml/2006/main">
+            <a:off x="619125" y="4391025"/>
+            <a:ext cx="1752600" cy="400050"/>
+          </a:xfrm>
+          <a:prstGeom xmlns:a="http://schemas.openxmlformats.org/drawingml/2006/main" prst="rect">
+            <a:avLst/>
+          </a:prstGeom>
+          <a:noFill xmlns:a="http://schemas.openxmlformats.org/drawingml/2006/main"/>
+          <a:ln xmlns:a="http://schemas.openxmlformats.org/drawingml/2006/main" w="0">
+            <a:noFill/>
+          </a:ln>
+        </p:spPr>
+        <p:txBody>
+          <a:bodyPr xmlns:a="http://schemas.openxmlformats.org/drawingml/2006/main" wrap="square" lIns="0" tIns="0" rIns="0" bIns="0" anchor="t">
+            <a:noAutofit/>
+          </a:bodyPr>
+          <a:lstStyle xmlns:a="http://schemas.openxmlformats.org/drawingml/2006/main">
+            <a:defPPr algn="l">
+              <a:defRPr sz="2025" b="1">
+                <a:solidFill>
+                  <a:srgbClr val="061747"/>
+                </a:solidFill>
+                <a:latin typeface="Nimbus Sans"/>
+                <a:ea typeface="Nimbus Sans"/>
+                <a:cs typeface="Nimbus Sans"/>
+              </a:defRPr>
+            </a:defPPr>
+          </a:lstStyle>
+          <a:p xmlns:a="http://schemas.openxmlformats.org/drawingml/2006/main">
+            <a:pPr algn="l">
+              <a:buNone/>
+              <a:defRPr sz="2175" b="1">
+                <a:solidFill>
+                  <a:srgbClr val="061747"/>
+                </a:solidFill>
+                <a:latin typeface="Nimbus Sans"/>
+                <a:ea typeface="Nimbus Sans"/>
+                <a:cs typeface="Nimbus Sans"/>
+              </a:defRPr>
+            </a:pPr>
+            <a:r>
+              <a:rPr sz="2025" b="1">
+                <a:solidFill>
+                  <a:srgbClr val="061747"/>
+                </a:solidFill>
+                <a:latin typeface="Nimbus Sans"/>
+                <a:ea typeface="Nimbus Sans"/>
+                <a:cs typeface="Nimbus Sans"/>
+              </a:rPr>
+              <a:t>Guardrails</a:t>
+            </a:r>
+          </a:p>
+        </p:txBody>
+      </p:sp>
+      <p:sp>
+        <p:nvSpPr>
+          <p:cNvPr id="16" name="Freeze the model and scoring rule, then compare once on the rese">
+            <a:extLst xmlns:a="http://schemas.openxmlformats.org/drawingml/2006/main">
+              <a:ext uri="{FF2B5EF4-FFF2-40B4-BE49-F238E27FC236}">
+                <a16:creationId xmlns:a16="http://schemas.microsoft.com/office/drawing/2014/main" id="{2AA6AD31-68DE-4EAE-B741-1DB1D82DEE38}"/>
+              </a:ext>
+            </a:extLst>
+          </p:cNvPr>
+          <p:cNvSpPr>
+            <a:spLocks xmlns:a="http://schemas.openxmlformats.org/drawingml/2006/main" noGrp="1"/>
+          </p:cNvSpPr>
+          <p:nvPr/>
+        </p:nvSpPr>
+        <p:spPr>
+          <a:xfrm xmlns:a="http://schemas.openxmlformats.org/drawingml/2006/main">
+            <a:off x="2466975" y="4352925"/>
+            <a:ext cx="8943975" cy="866775"/>
+          </a:xfrm>
+          <a:prstGeom xmlns:a="http://schemas.openxmlformats.org/drawingml/2006/main" prst="rect">
+            <a:avLst/>
+          </a:prstGeom>
+          <a:noFill xmlns:a="http://schemas.openxmlformats.org/drawingml/2006/main"/>
+          <a:ln xmlns:a="http://schemas.openxmlformats.org/drawingml/2006/main" w="0">
+            <a:noFill/>
+          </a:ln>
+        </p:spPr>
+        <p:txBody>
+          <a:bodyPr xmlns:a="http://schemas.openxmlformats.org/drawingml/2006/main" wrap="square" lIns="0" tIns="0" rIns="0" bIns="0" anchor="t">
+            <a:noAutofit/>
+          </a:bodyPr>
+          <a:lstStyle xmlns:a="http://schemas.openxmlformats.org/drawingml/2006/main">
+            <a:defPPr algn="l">
+              <a:defRPr sz="1725" b="0">
+                <a:solidFill>
+                  <a:srgbClr val="061747"/>
+                </a:solidFill>
+                <a:latin typeface="Nimbus Sans"/>
+                <a:ea typeface="Nimbus Sans"/>
+                <a:cs typeface="Nimbus Sans"/>
+              </a:defRPr>
+            </a:defPPr>
+          </a:lstStyle>
+          <a:p xmlns:a="http://schemas.openxmlformats.org/drawingml/2006/main">
+            <a:pPr algn="l">
+              <a:buNone/>
+              <a:defRPr sz="1725" b="0">
+                <a:solidFill>
+                  <a:srgbClr val="061747"/>
+                </a:solidFill>
+                <a:latin typeface="Nimbus Sans"/>
+                <a:ea typeface="Nimbus Sans"/>
+                <a:cs typeface="Nimbus Sans"/>
+              </a:defRPr>
+            </a:pPr>
+            <a:r>
+              <a:rPr sz="1725" b="0">
+                <a:solidFill>
+                  <a:srgbClr val="061747"/>
+                </a:solidFill>
+                <a:latin typeface="Nimbus Sans"/>
+                <a:ea typeface="Nimbus Sans"/>
+                <a:cs typeface="Nimbus Sans"/>
+              </a:rPr>
+              <a:t>Use consented, de-identified data. Report cohort estimates with uncertainty and baseline comparisons. Check subgroup errors and population fit; confirm findings with new human responses.</a:t>
+            </a:r>
+          </a:p>
+        </p:txBody>
+      </p:sp>
+      <p:sp>
+        <p:nvSpPr>
+          <p:cNvPr id="18" name="prohibited-label">
+            <a:extLst xmlns:a="http://schemas.openxmlformats.org/drawingml/2006/main">
+              <a:ext uri="{FF2B5EF4-FFF2-40B4-BE49-F238E27FC236}">
+                <a16:creationId xmlns:a16="http://schemas.microsoft.com/office/drawing/2014/main" id="{E8347CD7-4D9B-4C37-BCED-83571CE5FCFD}"/>
+              </a:ext>
+            </a:extLst>
+          </p:cNvPr>
+          <p:cNvSpPr>
+            <a:spLocks xmlns:a="http://schemas.openxmlformats.org/drawingml/2006/main" noGrp="1"/>
+          </p:cNvSpPr>
+          <p:nvPr/>
+        </p:nvSpPr>
+        <p:spPr>
+          <a:xfrm xmlns:a="http://schemas.openxmlformats.org/drawingml/2006/main">
+            <a:off x="619125" y="5391150"/>
+            <a:ext cx="1790700" cy="457200"/>
+          </a:xfrm>
+          <a:prstGeom xmlns:a="http://schemas.openxmlformats.org/drawingml/2006/main" prst="rect">
+            <a:avLst/>
+          </a:prstGeom>
+          <a:noFill xmlns:a="http://schemas.openxmlformats.org/drawingml/2006/main"/>
+          <a:ln xmlns:a="http://schemas.openxmlformats.org/drawingml/2006/main" w="0">
+            <a:noFill/>
+          </a:ln>
+        </p:spPr>
+        <p:txBody>
+          <a:bodyPr xmlns:a="http://schemas.openxmlformats.org/drawingml/2006/main" lIns="0" tIns="0" rIns="0" bIns="0" anchor="t"/>
+          <a:lstStyle xmlns:a="http://schemas.openxmlformats.org/drawingml/2006/main">
+            <a:defPPr>
+              <a:defRPr sz="2025" b="1">
+                <a:solidFill>
+                  <a:srgbClr val="061747"/>
+                </a:solidFill>
+                <a:latin typeface="Nimbus Sans"/>
+                <a:ea typeface="Nimbus Sans"/>
+                <a:cs typeface="Nimbus Sans"/>
+              </a:defRPr>
+            </a:defPPr>
+          </a:lstStyle>
+          <a:p xmlns:a="http://schemas.openxmlformats.org/drawingml/2006/main">
+            <a:pPr>
+              <a:defRPr sz="2025" b="1">
+                <a:solidFill>
+                  <a:srgbClr val="061747"/>
+                </a:solidFill>
+                <a:latin typeface="Nimbus Sans"/>
+                <a:ea typeface="Nimbus Sans"/>
+                <a:cs typeface="Nimbus Sans"/>
+              </a:defRPr>
+            </a:pPr>
+            <a:r>
+              <a:rPr sz="2025" b="1">
+                <a:solidFill>
+                  <a:srgbClr val="061747"/>
+                </a:solidFill>
+                <a:latin typeface="Nimbus Sans"/>
+                <a:ea typeface="Nimbus Sans"/>
+                <a:cs typeface="Nimbus Sans"/>
+              </a:rPr>
+              <a:t>Do not use for</a:t>
+            </a:r>
+          </a:p>
+        </p:txBody>
+      </p:sp>
+      <p:sp>
+        <p:nvSpPr>
+          <p:cNvPr id="19" name="prohibited-details">
+            <a:extLst xmlns:a="http://schemas.openxmlformats.org/drawingml/2006/main">
+              <a:ext uri="{FF2B5EF4-FFF2-40B4-BE49-F238E27FC236}">
+                <a16:creationId xmlns:a16="http://schemas.microsoft.com/office/drawing/2014/main" id="{517AC2A7-D230-4E2B-8652-F2EB76941397}"/>
+              </a:ext>
+            </a:extLst>
+          </p:cNvPr>
+          <p:cNvSpPr>
+            <a:spLocks xmlns:a="http://schemas.openxmlformats.org/drawingml/2006/main" noGrp="1"/>
+          </p:cNvSpPr>
+          <p:nvPr/>
+        </p:nvSpPr>
+        <p:spPr>
+          <a:xfrm xmlns:a="http://schemas.openxmlformats.org/drawingml/2006/main">
+            <a:off x="2466975" y="5343525"/>
+            <a:ext cx="8943975" cy="714375"/>
+          </a:xfrm>
+          <a:prstGeom xmlns:a="http://schemas.openxmlformats.org/drawingml/2006/main" prst="rect">
+            <a:avLst/>
+          </a:prstGeom>
+          <a:noFill xmlns:a="http://schemas.openxmlformats.org/drawingml/2006/main"/>
+          <a:ln xmlns:a="http://schemas.openxmlformats.org/drawingml/2006/main" w="0">
+            <a:noFill/>
+          </a:ln>
+        </p:spPr>
+        <p:txBody>
+          <a:bodyPr xmlns:a="http://schemas.openxmlformats.org/drawingml/2006/main" lIns="0" tIns="0" rIns="0" bIns="0" anchor="t"/>
+          <a:lstStyle xmlns:a="http://schemas.openxmlformats.org/drawingml/2006/main">
+            <a:defPPr>
+              <a:defRPr sz="1725">
+                <a:solidFill>
+                  <a:srgbClr val="061747"/>
+                </a:solidFill>
+                <a:latin typeface="Nimbus Sans"/>
+                <a:ea typeface="Nimbus Sans"/>
+                <a:cs typeface="Nimbus Sans"/>
+              </a:defRPr>
+            </a:defPPr>
+          </a:lstStyle>
+          <a:p xmlns:a="http://schemas.openxmlformats.org/drawingml/2006/main">
+            <a:pPr>
+              <a:defRPr sz="1725">
+                <a:solidFill>
+                  <a:srgbClr val="061747"/>
+                </a:solidFill>
+                <a:latin typeface="Nimbus Sans"/>
+                <a:ea typeface="Nimbus Sans"/>
+                <a:cs typeface="Nimbus Sans"/>
+              </a:defRPr>
+            </a:pPr>
+            <a:r>
+              <a:rPr sz="1725">
+                <a:solidFill>
+                  <a:srgbClr val="061747"/>
+                </a:solidFill>
+                <a:latin typeface="Nimbus Sans"/>
+                <a:ea typeface="Nimbus Sans"/>
+                <a:cs typeface="Nimbus Sans"/>
+              </a:rPr>
+              <a:t>Individual hiring, credit, insurance or medical decisions; covert profiling or manipulation; presenting simulated answers as real customer evidence.</a:t>
+            </a:r>
+          </a:p>
+        </p:txBody>
+      </p:sp>
+    </p:spTree>
+    <p:extLst>
+      <p:ext uri="{BB962C8B-B14F-4D97-AF65-F5344CB8AC3E}">
+        <p14:creationId xmlns:p14="http://schemas.microsoft.com/office/powerpoint/2010/main" val="1569414947"/>
+      </p:ext>
+    </p:extLst>
+  </p:cSld>
+</p:sld>
+</file>
+
+<file path=ppt/slides/slide18.xml><?xml version="1.0" encoding="utf-8"?>
 <p:sld xmlns:p="http://schemas.openxmlformats.org/presentationml/2006/main">
   <p:cSld>
     <p:bg>
@@ -16727,7 +17937,7 @@
                 <a:ea typeface="Nimbus Sans"/>
                 <a:cs typeface="Nimbus Sans"/>
               </a:rPr>
-              <a:t>17</a:t>
+              <a:t>18</a:t>
             </a:r>
           </a:p>
         </p:txBody>
@@ -18677,7 +19887,7 @@
                 <a:ea typeface="Nimbus Sans"/>
                 <a:cs typeface="Nimbus Sans"/>
               </a:rPr>
-              <a:t>Findings and limitations</a:t>
+              <a:t>Applications and findings</a:t>
             </a:r>
           </a:p>
         </p:txBody>
@@ -18746,7 +19956,7 @@
                 <a:ea typeface="Nimbus Sans"/>
                 <a:cs typeface="Nimbus Sans"/>
               </a:rPr>
-              <a:t>What the experiments establish and the proposed next step</a:t>
+              <a:t>Proposed uses, guardrails, findings and the next step</a:t>
             </a:r>
           </a:p>
         </p:txBody>
@@ -18815,7 +20025,7 @@
                 <a:ea typeface="Nimbus Sans"/>
                 <a:cs typeface="Nimbus Sans"/>
               </a:rPr>
-              <a:t>Slide 17</a:t>
+              <a:t>Slides 17–18</a:t>
             </a:r>
           </a:p>
         </p:txBody>
@@ -20156,7 +21366,7 @@
           <p:cNvPr id="18" name="">
             <a:extLst xmlns:a="http://schemas.openxmlformats.org/drawingml/2006/main">
               <a:ext uri="{FF2B5EF4-FFF2-40B4-BE49-F238E27FC236}">
-                <a16:creationId xmlns:a16="http://schemas.microsoft.com/office/drawing/2014/main" id="{159CC72B-A3CB-46E0-817F-3C32831ED573}"/>
+                <a16:creationId xmlns:a16="http://schemas.microsoft.com/office/drawing/2014/main" id="{71DB6D70-F20A-40B4-895B-FAB4AD794A66}"/>
               </a:ext>
             </a:extLst>
           </p:cNvPr>
@@ -21006,7 +22216,7 @@
           <p:cNvPr id="10" name="">
             <a:extLst xmlns:a="http://schemas.openxmlformats.org/drawingml/2006/main">
               <a:ext uri="{FF2B5EF4-FFF2-40B4-BE49-F238E27FC236}">
-                <a16:creationId xmlns:a16="http://schemas.microsoft.com/office/drawing/2014/main" id="{5DEF0221-4D85-4BF3-9213-A665F598D2F5}"/>
+                <a16:creationId xmlns:a16="http://schemas.microsoft.com/office/drawing/2014/main" id="{CC45748D-F169-4CCF-BC0B-43EDDE0C012B}"/>
               </a:ext>
             </a:extLst>
           </p:cNvPr>
@@ -21470,7 +22680,7 @@
           <p:cNvPr id="13" name="">
             <a:extLst xmlns:a="http://schemas.openxmlformats.org/drawingml/2006/main">
               <a:ext uri="{FF2B5EF4-FFF2-40B4-BE49-F238E27FC236}">
-                <a16:creationId xmlns:a16="http://schemas.microsoft.com/office/drawing/2014/main" id="{B7C192AB-AB1B-4313-A3D6-0BD6AFEEB5BD}"/>
+                <a16:creationId xmlns:a16="http://schemas.microsoft.com/office/drawing/2014/main" id="{F73F5735-1FF1-4121-B7CB-6C2689104527}"/>
               </a:ext>
             </a:extLst>
           </p:cNvPr>
@@ -22421,7 +23631,7 @@
           <p:cNvPr id="6" name="">
             <a:extLst xmlns:a="http://schemas.openxmlformats.org/drawingml/2006/main">
               <a:ext uri="{FF2B5EF4-FFF2-40B4-BE49-F238E27FC236}">
-                <a16:creationId xmlns:a16="http://schemas.microsoft.com/office/drawing/2014/main" id="{531A734A-5E2E-4049-B194-6B77D6778662}"/>
+                <a16:creationId xmlns:a16="http://schemas.microsoft.com/office/drawing/2014/main" id="{C31CAF39-B0BB-48BB-BD56-C6453831DEFE}"/>
               </a:ext>
             </a:extLst>
           </p:cNvPr>
@@ -23356,6 +24566,7 @@
           </a:lstStyle>
           <a:p xmlns:a="http://schemas.openxmlformats.org/drawingml/2006/main">
             <a:pPr algn="l">
+              <a:buNone/>
               <a:defRPr sz="3075" b="1">
                 <a:solidFill>
                   <a:srgbClr val="061747"/>
@@ -23424,6 +24635,7 @@
           </a:lstStyle>
           <a:p xmlns:a="http://schemas.openxmlformats.org/drawingml/2006/main">
             <a:pPr algn="l">
+              <a:buNone/>
               <a:defRPr sz="1500" b="0">
                 <a:solidFill>
                   <a:srgbClr val="637B9C"/>
@@ -23572,6 +24784,7 @@
           </a:lstStyle>
           <a:p xmlns:a="http://schemas.openxmlformats.org/drawingml/2006/main">
             <a:pPr algn="l">
+              <a:buNone/>
               <a:defRPr sz="2175" b="1">
                 <a:solidFill>
                   <a:srgbClr val="1673FF"/>
@@ -23640,6 +24853,7 @@
           </a:lstStyle>
           <a:p xmlns:a="http://schemas.openxmlformats.org/drawingml/2006/main">
             <a:pPr algn="l">
+              <a:buNone/>
               <a:defRPr sz="1575" b="0">
                 <a:solidFill>
                   <a:srgbClr val="637B9C"/>
@@ -23668,7 +24882,7 @@
           <p:cNvPr id="7" name="">
             <a:extLst xmlns:a="http://schemas.openxmlformats.org/drawingml/2006/main">
               <a:ext uri="{FF2B5EF4-FFF2-40B4-BE49-F238E27FC236}">
-                <a16:creationId xmlns:a16="http://schemas.microsoft.com/office/drawing/2014/main" id="{18B230BA-D211-4296-8070-3A56F81C1EC5}"/>
+                <a16:creationId xmlns:a16="http://schemas.microsoft.com/office/drawing/2014/main" id="{8B53F200-EFA6-4EB7-B6DB-6168B7290CF5}"/>
               </a:ext>
             </a:extLst>
           </p:cNvPr>
@@ -23693,7 +24907,9 @@
                     <a:bodyPr/>
                     <a:lstStyle/>
                     <a:p>
-                      <a:pPr algn="l"/>
+                      <a:pPr algn="l">
+                        <a:buNone/>
+                      </a:pPr>
                       <a:r>
                         <a:rPr sz="1500" b="1">
                           <a:solidFill>
@@ -23742,7 +24958,9 @@
                     <a:bodyPr/>
                     <a:lstStyle/>
                     <a:p>
-                      <a:pPr algn="ctr"/>
+                      <a:pPr algn="ctr">
+                        <a:buNone/>
+                      </a:pPr>
                       <a:r>
                         <a:rPr sz="1500" b="1">
                           <a:solidFill>
@@ -23787,7 +25005,9 @@
                     <a:bodyPr/>
                     <a:lstStyle/>
                     <a:p>
-                      <a:pPr algn="l"/>
+                      <a:pPr algn="l">
+                        <a:buNone/>
+                      </a:pPr>
                       <a:r>
                         <a:rPr sz="1500" b="0">
                           <a:solidFill>
@@ -23830,7 +25050,9 @@
                     <a:bodyPr/>
                     <a:lstStyle/>
                     <a:p>
-                      <a:pPr algn="ctr"/>
+                      <a:pPr algn="ctr">
+                        <a:buNone/>
+                      </a:pPr>
                       <a:r>
                         <a:rPr sz="1500" b="0">
                           <a:solidFill>
@@ -23869,7 +25091,9 @@
                     <a:bodyPr/>
                     <a:lstStyle/>
                     <a:p>
-                      <a:pPr algn="l"/>
+                      <a:pPr algn="l">
+                        <a:buNone/>
+                      </a:pPr>
                       <a:r>
                         <a:rPr sz="1500" b="0">
                           <a:solidFill>
@@ -23912,7 +25136,9 @@
                     <a:bodyPr/>
                     <a:lstStyle/>
                     <a:p>
-                      <a:pPr algn="ctr"/>
+                      <a:pPr algn="ctr">
+                        <a:buNone/>
+                      </a:pPr>
                       <a:r>
                         <a:rPr sz="1500" b="0">
                           <a:solidFill>
@@ -23951,7 +25177,9 @@
                     <a:bodyPr/>
                     <a:lstStyle/>
                     <a:p>
-                      <a:pPr algn="l"/>
+                      <a:pPr algn="l">
+                        <a:buNone/>
+                      </a:pPr>
                       <a:r>
                         <a:rPr sz="1500" b="0">
                           <a:solidFill>
@@ -23994,7 +25222,9 @@
                     <a:bodyPr/>
                     <a:lstStyle/>
                     <a:p>
-                      <a:pPr algn="ctr"/>
+                      <a:pPr algn="ctr">
+                        <a:buNone/>
+                      </a:pPr>
                       <a:r>
                         <a:rPr sz="1500" b="0">
                           <a:solidFill>
@@ -24033,7 +25263,9 @@
                     <a:bodyPr/>
                     <a:lstStyle/>
                     <a:p>
-                      <a:pPr algn="l"/>
+                      <a:pPr algn="l">
+                        <a:buNone/>
+                      </a:pPr>
                       <a:r>
                         <a:rPr sz="1500" b="0">
                           <a:solidFill>
@@ -24076,7 +25308,9 @@
                     <a:bodyPr/>
                     <a:lstStyle/>
                     <a:p>
-                      <a:pPr algn="ctr"/>
+                      <a:pPr algn="ctr">
+                        <a:buNone/>
+                      </a:pPr>
                       <a:r>
                         <a:rPr sz="1500" b="0">
                           <a:solidFill>
@@ -24115,7 +25349,9 @@
                     <a:bodyPr/>
                     <a:lstStyle/>
                     <a:p>
-                      <a:pPr algn="l"/>
+                      <a:pPr algn="l">
+                        <a:buNone/>
+                      </a:pPr>
                       <a:r>
                         <a:rPr sz="1500" b="0">
                           <a:solidFill>
@@ -24158,7 +25394,9 @@
                     <a:bodyPr/>
                     <a:lstStyle/>
                     <a:p>
-                      <a:pPr algn="ctr"/>
+                      <a:pPr algn="ctr">
+                        <a:buNone/>
+                      </a:pPr>
                       <a:r>
                         <a:rPr sz="1500" b="0">
                           <a:solidFill>
@@ -24240,6 +25478,7 @@
           </a:lstStyle>
           <a:p xmlns:a="http://schemas.openxmlformats.org/drawingml/2006/main">
             <a:pPr algn="l">
+              <a:buNone/>
               <a:defRPr sz="1500" b="1">
                 <a:solidFill>
                   <a:srgbClr val="061747"/>
@@ -24308,6 +25547,7 @@
           </a:lstStyle>
           <a:p xmlns:a="http://schemas.openxmlformats.org/drawingml/2006/main">
             <a:pPr algn="l">
+              <a:buNone/>
               <a:defRPr sz="1425" b="0">
                 <a:solidFill>
                   <a:srgbClr val="637B9C"/>
@@ -24376,6 +25616,7 @@
           </a:lstStyle>
           <a:p xmlns:a="http://schemas.openxmlformats.org/drawingml/2006/main">
             <a:pPr algn="l">
+              <a:buNone/>
               <a:defRPr sz="2175" b="1">
                 <a:solidFill>
                   <a:srgbClr val="009E9A"/>
@@ -24444,6 +25685,7 @@
           </a:lstStyle>
           <a:p xmlns:a="http://schemas.openxmlformats.org/drawingml/2006/main">
             <a:pPr algn="l">
+              <a:buNone/>
               <a:defRPr sz="1575" b="0">
                 <a:solidFill>
                   <a:srgbClr val="637B9C"/>
@@ -24512,6 +25754,7 @@
           </a:lstStyle>
           <a:p xmlns:a="http://schemas.openxmlformats.org/drawingml/2006/main">
             <a:pPr algn="l">
+              <a:buNone/>
               <a:defRPr sz="1500" b="0">
                 <a:solidFill>
                   <a:srgbClr val="061747"/>
@@ -24535,6 +25778,7 @@
           </a:p>
           <a:p xmlns:a="http://schemas.openxmlformats.org/drawingml/2006/main">
             <a:pPr algn="l">
+              <a:buNone/>
               <a:defRPr sz="1500" b="0">
                 <a:solidFill>
                   <a:srgbClr val="061747"/>
@@ -24603,6 +25847,7 @@
           </a:lstStyle>
           <a:p xmlns:a="http://schemas.openxmlformats.org/drawingml/2006/main">
             <a:pPr algn="l">
+              <a:buNone/>
               <a:defRPr sz="1650" b="1">
                 <a:solidFill>
                   <a:srgbClr val="061747"/>
@@ -24631,7 +25876,7 @@
           <p:cNvPr id="14" name="">
             <a:extLst xmlns:a="http://schemas.openxmlformats.org/drawingml/2006/main">
               <a:ext uri="{FF2B5EF4-FFF2-40B4-BE49-F238E27FC236}">
-                <a16:creationId xmlns:a16="http://schemas.microsoft.com/office/drawing/2014/main" id="{0031E33D-7FD3-43EB-A0AE-1CEC37D3959F}"/>
+                <a16:creationId xmlns:a16="http://schemas.microsoft.com/office/drawing/2014/main" id="{03A2508B-D728-4BA1-B717-20AB81F4108F}"/>
               </a:ext>
             </a:extLst>
           </p:cNvPr>
@@ -24657,7 +25902,9 @@
                     <a:bodyPr/>
                     <a:lstStyle/>
                     <a:p>
-                      <a:pPr algn="l"/>
+                      <a:pPr algn="l">
+                        <a:buNone/>
+                      </a:pPr>
                       <a:r>
                         <a:rPr sz="1500" b="1">
                           <a:solidFill>
@@ -24706,7 +25953,9 @@
                     <a:bodyPr/>
                     <a:lstStyle/>
                     <a:p>
-                      <a:pPr algn="ctr"/>
+                      <a:pPr algn="ctr">
+                        <a:buNone/>
+                      </a:pPr>
                       <a:r>
                         <a:rPr sz="1500" b="1">
                           <a:solidFill>
@@ -24749,7 +25998,9 @@
                     <a:bodyPr/>
                     <a:lstStyle/>
                     <a:p>
-                      <a:pPr algn="ctr"/>
+                      <a:pPr algn="ctr">
+                        <a:buNone/>
+                      </a:pPr>
                       <a:r>
                         <a:rPr sz="1500" b="1">
                           <a:solidFill>
@@ -24794,7 +26045,9 @@
                     <a:bodyPr/>
                     <a:lstStyle/>
                     <a:p>
-                      <a:pPr algn="l"/>
+                      <a:pPr algn="l">
+                        <a:buNone/>
+                      </a:pPr>
                       <a:r>
                         <a:rPr sz="1500" b="0">
                           <a:solidFill>
@@ -24837,7 +26090,9 @@
                     <a:bodyPr/>
                     <a:lstStyle/>
                     <a:p>
-                      <a:pPr algn="ctr"/>
+                      <a:pPr algn="ctr">
+                        <a:buNone/>
+                      </a:pPr>
                       <a:r>
                         <a:rPr sz="1500" b="0">
                           <a:solidFill>
@@ -24874,7 +26129,9 @@
                     <a:bodyPr/>
                     <a:lstStyle/>
                     <a:p>
-                      <a:pPr algn="ctr"/>
+                      <a:pPr algn="ctr">
+                        <a:buNone/>
+                      </a:pPr>
                       <a:r>
                         <a:rPr sz="1500" b="0">
                           <a:solidFill>
@@ -24956,6 +26213,7 @@
           </a:lstStyle>
           <a:p xmlns:a="http://schemas.openxmlformats.org/drawingml/2006/main">
             <a:pPr algn="l">
+              <a:buNone/>
               <a:defRPr sz="1200" b="0">
                 <a:solidFill>
                   <a:srgbClr val="637B9C"/>
@@ -25024,6 +26282,7 @@
           </a:lstStyle>
           <a:p xmlns:a="http://schemas.openxmlformats.org/drawingml/2006/main">
             <a:pPr algn="l">
+              <a:buNone/>
               <a:defRPr sz="1500" b="0">
                 <a:solidFill>
                   <a:srgbClr val="061747"/>
@@ -25047,6 +26306,7 @@
           </a:p>
           <a:p xmlns:a="http://schemas.openxmlformats.org/drawingml/2006/main">
             <a:pPr algn="l">
+              <a:buNone/>
               <a:defRPr sz="1500" b="0">
                 <a:solidFill>
                   <a:srgbClr val="061747"/>
@@ -25145,6 +26405,7 @@
           </a:lstStyle>
           <a:p xmlns:a="http://schemas.openxmlformats.org/drawingml/2006/main">
             <a:pPr algn="l">
+              <a:buNone/>
               <a:defRPr sz="1050" b="0">
                 <a:solidFill>
                   <a:srgbClr val="637B9C"/>
@@ -25213,6 +26474,7 @@
           </a:lstStyle>
           <a:p xmlns:a="http://schemas.openxmlformats.org/drawingml/2006/main">
             <a:pPr algn="r">
+              <a:buNone/>
               <a:defRPr sz="1125" b="0">
                 <a:solidFill>
                   <a:srgbClr val="637B9C"/>
@@ -25576,7 +26838,7 @@
           <p:cNvPr id="6" name="">
             <a:extLst xmlns:a="http://schemas.openxmlformats.org/drawingml/2006/main">
               <a:ext uri="{FF2B5EF4-FFF2-40B4-BE49-F238E27FC236}">
-                <a16:creationId xmlns:a16="http://schemas.microsoft.com/office/drawing/2014/main" id="{F9DA2A28-98CE-4FBA-AB72-3E8BAD1400A8}"/>
+                <a16:creationId xmlns:a16="http://schemas.microsoft.com/office/drawing/2014/main" id="{4D857A85-221C-4021-BFB1-A084E2EA16A8}"/>
               </a:ext>
             </a:extLst>
           </p:cNvPr>
@@ -26913,7 +28175,7 @@
           <p:cNvPr id="6" name="">
             <a:extLst xmlns:a="http://schemas.openxmlformats.org/drawingml/2006/main">
               <a:ext uri="{FF2B5EF4-FFF2-40B4-BE49-F238E27FC236}">
-                <a16:creationId xmlns:a16="http://schemas.microsoft.com/office/drawing/2014/main" id="{9DC64CBD-9E3B-4D32-A408-EE5CC5712581}"/>
+                <a16:creationId xmlns:a16="http://schemas.microsoft.com/office/drawing/2014/main" id="{4EAA1027-BC26-4E8F-BD28-D8E06532F652}"/>
               </a:ext>
             </a:extLst>
           </p:cNvPr>
@@ -28150,7 +29412,7 @@
           <p:cNvPr id="6" name="Chart">
             <a:extLst xmlns:a="http://schemas.openxmlformats.org/drawingml/2006/main">
               <a:ext uri="{FF2B5EF4-FFF2-40B4-BE49-F238E27FC236}">
-                <a16:creationId xmlns:a16="http://schemas.microsoft.com/office/drawing/2014/main" id="{A82CF6B8-6837-45C8-9C45-151A97DE70AA}"/>
+                <a16:creationId xmlns:a16="http://schemas.microsoft.com/office/drawing/2014/main" id="{537067EB-096D-4960-A29F-48CC0CEC52F0}"/>
               </a:ext>
             </a:extLst>
           </p:cNvPr>
@@ -28163,7 +29425,7 @@
         </p:xfrm>
         <a:graphic xmlns:a="http://schemas.openxmlformats.org/drawingml/2006/main">
           <a:graphicData uri="http://schemas.openxmlformats.org/drawingml/2006/chart">
-            <c:chart xmlns:r="http://schemas.openxmlformats.org/officeDocument/2006/relationships" xmlns:c="http://schemas.openxmlformats.org/drawingml/2006/chart" r:id="R34adb2070cf240fc"/>
+            <c:chart xmlns:r="http://schemas.openxmlformats.org/officeDocument/2006/relationships" xmlns:c="http://schemas.openxmlformats.org/drawingml/2006/chart" r:id="Rc00471a216a44071"/>
           </a:graphicData>
         </a:graphic>
       </p:graphicFrame>

</xml_diff>